<commit_message>
docs: add ‹code› reference footer to every slide in both decks
Each slide now carries a monospace ‹code› footer linking it to the real
implementation — an excerpt where the layout allows, otherwise file:line
(or a docs/evolution_design_notes.md §section pointer for conceptual
slides). Regenerated both .pptx from source.

- docs/slides/build.js — deck 1 (OpenEvolve × CrewAI), 23 slides
- docs/slides/build_collab.js — deck 2 (three-layer collaboration), 26 slides
- codeRef() helper added to both; dark variant for NAVY slides
- minor: nudged two notes up so the footer never overlaps content

Co-Authored-By: Claude Opus 4.8 <noreply@anthropic.com>
</commit_message>
<xml_diff>
--- a/docs/slides/OpenEvolve_CrewAI_教學投影片.pptx
+++ b/docs/slides/OpenEvolve_CrewAI_教學投影片.pptx
@@ -4018,6 +4018,59 @@
           </a:p>
         </p:txBody>
       </p:sp>
+      <p:sp>
+        <p:nvSpPr>
+          <p:cNvPr id="7" name="Text 5"/>
+          <p:cNvSpPr/>
+          <p:nvPr/>
+        </p:nvSpPr>
+        <p:spPr>
+          <a:xfrm>
+            <a:off x="502920" y="6583680"/>
+            <a:ext cx="11338560" cy="201168"/>
+          </a:xfrm>
+          <a:prstGeom prst="rect">
+            <a:avLst/>
+          </a:prstGeom>
+          <a:noFill/>
+          <a:ln/>
+        </p:spPr>
+        <p:txBody>
+          <a:bodyPr wrap="square" lIns="0" tIns="0" rIns="0" bIns="0" rtlCol="0" anchor="ctr"/>
+          <a:lstStyle/>
+          <a:p>
+            <a:pPr indent="0" marL="0">
+              <a:buNone/>
+            </a:pPr>
+            <a:r>
+              <a:rPr lang="en-US" sz="900" b="1" dirty="0">
+                <a:solidFill>
+                  <a:srgbClr val="E8A33D"/>
+                </a:solidFill>
+                <a:latin typeface="Consolas" pitchFamily="34" charset="0"/>
+                <a:ea typeface="Consolas" pitchFamily="34" charset="-122"/>
+                <a:cs typeface="Consolas" pitchFamily="34" charset="-120"/>
+              </a:rPr>
+              <a:t>‹code›  </a:t>
+            </a:r>
+            <a:pPr indent="0" marL="0">
+              <a:buNone/>
+            </a:pPr>
+            <a:r>
+              <a:rPr lang="en-US" sz="900" dirty="0">
+                <a:solidFill>
+                  <a:srgbClr val="8FA3C8"/>
+                </a:solidFill>
+                <a:latin typeface="Consolas" pitchFamily="34" charset="0"/>
+                <a:ea typeface="Consolas" pitchFamily="34" charset="-122"/>
+                <a:cs typeface="Consolas" pitchFamily="34" charset="-120"/>
+              </a:rPr>
+              <a:t>進入點：config/openevolve_config.yaml · openevolve_evaluator.py · config/agents_evolving.yaml</a:t>
+            </a:r>
+            <a:endParaRPr lang="en-US" sz="900" dirty="0"/>
+          </a:p>
+        </p:txBody>
+      </p:sp>
     </p:spTree>
   </p:cSld>
   <p:clrMapOvr>
@@ -4461,6 +4514,59 @@
           </a:p>
         </p:txBody>
       </p:sp>
+      <p:sp>
+        <p:nvSpPr>
+          <p:cNvPr id="14" name="Text 12"/>
+          <p:cNvSpPr/>
+          <p:nvPr/>
+        </p:nvSpPr>
+        <p:spPr>
+          <a:xfrm>
+            <a:off x="502920" y="6583680"/>
+            <a:ext cx="11338560" cy="201168"/>
+          </a:xfrm>
+          <a:prstGeom prst="rect">
+            <a:avLst/>
+          </a:prstGeom>
+          <a:noFill/>
+          <a:ln/>
+        </p:spPr>
+        <p:txBody>
+          <a:bodyPr wrap="square" lIns="0" tIns="0" rIns="0" bIns="0" rtlCol="0" anchor="ctr"/>
+          <a:lstStyle/>
+          <a:p>
+            <a:pPr indent="0" marL="0">
+              <a:buNone/>
+            </a:pPr>
+            <a:r>
+              <a:rPr lang="en-US" sz="900" b="1" dirty="0">
+                <a:solidFill>
+                  <a:srgbClr val="E8A33D"/>
+                </a:solidFill>
+                <a:latin typeface="Consolas" pitchFamily="34" charset="0"/>
+                <a:ea typeface="Consolas" pitchFamily="34" charset="-122"/>
+                <a:cs typeface="Consolas" pitchFamily="34" charset="-120"/>
+              </a:rPr>
+              <a:t>‹code›  </a:t>
+            </a:r>
+            <a:pPr indent="0" marL="0">
+              <a:buNone/>
+            </a:pPr>
+            <a:r>
+              <a:rPr lang="en-US" sz="900" dirty="0">
+                <a:solidFill>
+                  <a:srgbClr val="6B7280"/>
+                </a:solidFill>
+                <a:latin typeface="Consolas" pitchFamily="34" charset="0"/>
+                <a:ea typeface="Consolas" pitchFamily="34" charset="-122"/>
+                <a:cs typeface="Consolas" pitchFamily="34" charset="-120"/>
+              </a:rPr>
+              <a:t>協議：retrieval_executor.py:28-30 ALLOWED_QUERIES/STRATEGIES（凍結）｜策略：config/agents_evolving.yaml:11-16 retrieval_policy（進化）</a:t>
+            </a:r>
+            <a:endParaRPr lang="en-US" sz="900" dirty="0"/>
+          </a:p>
+        </p:txBody>
+      </p:sp>
     </p:spTree>
   </p:cSld>
   <p:clrMapOvr>
@@ -5223,8 +5329,8 @@
         </p:nvSpPr>
         <p:spPr>
           <a:xfrm>
-            <a:off x="548640" y="6172200"/>
-            <a:ext cx="10972800" cy="365760"/>
+            <a:off x="548640" y="6108192"/>
+            <a:ext cx="10972800" cy="274320"/>
           </a:xfrm>
           <a:prstGeom prst="rect">
             <a:avLst/>
@@ -5251,6 +5357,59 @@
               <a:t>每一層都遵守同一條安全憲法：最壞只是低分，不是崩潰。</a:t>
             </a:r>
             <a:endParaRPr lang="en-US" sz="1300" dirty="0"/>
+          </a:p>
+        </p:txBody>
+      </p:sp>
+      <p:sp>
+        <p:nvSpPr>
+          <p:cNvPr id="24" name="Text 22"/>
+          <p:cNvSpPr/>
+          <p:nvPr/>
+        </p:nvSpPr>
+        <p:spPr>
+          <a:xfrm>
+            <a:off x="502920" y="6583680"/>
+            <a:ext cx="11338560" cy="201168"/>
+          </a:xfrm>
+          <a:prstGeom prst="rect">
+            <a:avLst/>
+          </a:prstGeom>
+          <a:noFill/>
+          <a:ln/>
+        </p:spPr>
+        <p:txBody>
+          <a:bodyPr wrap="square" lIns="0" tIns="0" rIns="0" bIns="0" rtlCol="0" anchor="ctr"/>
+          <a:lstStyle/>
+          <a:p>
+            <a:pPr indent="0" marL="0">
+              <a:buNone/>
+            </a:pPr>
+            <a:r>
+              <a:rPr lang="en-US" sz="900" b="1" dirty="0">
+                <a:solidFill>
+                  <a:srgbClr val="E8A33D"/>
+                </a:solidFill>
+                <a:latin typeface="Consolas" pitchFamily="34" charset="0"/>
+                <a:ea typeface="Consolas" pitchFamily="34" charset="-122"/>
+                <a:cs typeface="Consolas" pitchFamily="34" charset="-120"/>
+              </a:rPr>
+              <a:t>‹code›  </a:t>
+            </a:r>
+            <a:pPr indent="0" marL="0">
+              <a:buNone/>
+            </a:pPr>
+            <a:r>
+              <a:rPr lang="en-US" sz="900" dirty="0">
+                <a:solidFill>
+                  <a:srgbClr val="6B7280"/>
+                </a:solidFill>
+                <a:latin typeface="Consolas" pitchFamily="34" charset="0"/>
+                <a:ea typeface="Consolas" pitchFamily="34" charset="-122"/>
+                <a:cs typeface="Consolas" pitchFamily="34" charset="-120"/>
+              </a:rPr>
+              <a:t>L0 interaction_tool_wrapper.py · L1 retrieval_executor.py · L2 tool_loader.py（皆在 src/tools/）</a:t>
+            </a:r>
+            <a:endParaRPr lang="en-US" sz="900" dirty="0"/>
           </a:p>
         </p:txBody>
       </p:sp>
@@ -5750,6 +5909,59 @@
           </a:p>
         </p:txBody>
       </p:sp>
+      <p:sp>
+        <p:nvSpPr>
+          <p:cNvPr id="13" name="Text 11"/>
+          <p:cNvSpPr/>
+          <p:nvPr/>
+        </p:nvSpPr>
+        <p:spPr>
+          <a:xfrm>
+            <a:off x="502920" y="6583680"/>
+            <a:ext cx="11338560" cy="201168"/>
+          </a:xfrm>
+          <a:prstGeom prst="rect">
+            <a:avLst/>
+          </a:prstGeom>
+          <a:noFill/>
+          <a:ln/>
+        </p:spPr>
+        <p:txBody>
+          <a:bodyPr wrap="square" lIns="0" tIns="0" rIns="0" bIns="0" rtlCol="0" anchor="ctr"/>
+          <a:lstStyle/>
+          <a:p>
+            <a:pPr indent="0" marL="0">
+              <a:buNone/>
+            </a:pPr>
+            <a:r>
+              <a:rPr lang="en-US" sz="900" b="1" dirty="0">
+                <a:solidFill>
+                  <a:srgbClr val="E8A33D"/>
+                </a:solidFill>
+                <a:latin typeface="Consolas" pitchFamily="34" charset="0"/>
+                <a:ea typeface="Consolas" pitchFamily="34" charset="-122"/>
+                <a:cs typeface="Consolas" pitchFamily="34" charset="-120"/>
+              </a:rPr>
+              <a:t>‹code›  </a:t>
+            </a:r>
+            <a:pPr indent="0" marL="0">
+              <a:buNone/>
+            </a:pPr>
+            <a:r>
+              <a:rPr lang="en-US" sz="900" dirty="0">
+                <a:solidFill>
+                  <a:srgbClr val="6B7280"/>
+                </a:solidFill>
+                <a:latin typeface="Consolas" pitchFamily="34" charset="0"/>
+                <a:ea typeface="Consolas" pitchFamily="34" charset="-122"/>
+                <a:cs typeface="Consolas" pitchFamily="34" charset="-120"/>
+              </a:rPr>
+              <a:t>interaction_tool_wrapper.py:17 _TOOL_CALL_LOG · :21 _record · :26 drain_tool_log ｜ openevolve_evaluator.py:31 _summarize_tool_use</a:t>
+            </a:r>
+            <a:endParaRPr lang="en-US" sz="900" dirty="0"/>
+          </a:p>
+        </p:txBody>
+      </p:sp>
     </p:spTree>
   </p:cSld>
   <p:clrMapOvr>
@@ -6338,6 +6550,59 @@
           </a:p>
         </p:txBody>
       </p:sp>
+      <p:sp>
+        <p:nvSpPr>
+          <p:cNvPr id="12" name="Text 10"/>
+          <p:cNvSpPr/>
+          <p:nvPr/>
+        </p:nvSpPr>
+        <p:spPr>
+          <a:xfrm>
+            <a:off x="502920" y="6583680"/>
+            <a:ext cx="11338560" cy="201168"/>
+          </a:xfrm>
+          <a:prstGeom prst="rect">
+            <a:avLst/>
+          </a:prstGeom>
+          <a:noFill/>
+          <a:ln/>
+        </p:spPr>
+        <p:txBody>
+          <a:bodyPr wrap="square" lIns="0" tIns="0" rIns="0" bIns="0" rtlCol="0" anchor="ctr"/>
+          <a:lstStyle/>
+          <a:p>
+            <a:pPr indent="0" marL="0">
+              <a:buNone/>
+            </a:pPr>
+            <a:r>
+              <a:rPr lang="en-US" sz="900" b="1" dirty="0">
+                <a:solidFill>
+                  <a:srgbClr val="E8A33D"/>
+                </a:solidFill>
+                <a:latin typeface="Consolas" pitchFamily="34" charset="0"/>
+                <a:ea typeface="Consolas" pitchFamily="34" charset="-122"/>
+                <a:cs typeface="Consolas" pitchFamily="34" charset="-120"/>
+              </a:rPr>
+              <a:t>‹code›  </a:t>
+            </a:r>
+            <a:pPr indent="0" marL="0">
+              <a:buNone/>
+            </a:pPr>
+            <a:r>
+              <a:rPr lang="en-US" sz="900" dirty="0">
+                <a:solidFill>
+                  <a:srgbClr val="6B7280"/>
+                </a:solidFill>
+                <a:latin typeface="Consolas" pitchFamily="34" charset="0"/>
+                <a:ea typeface="Consolas" pitchFamily="34" charset="-122"/>
+                <a:cs typeface="Consolas" pitchFamily="34" charset="-120"/>
+              </a:rPr>
+              <a:t>src/tools/retrieval_executor.py:44 _clamp_int · :53 normalize_policy（clamp）· :103 _sample_reviews · :140 execute_policy</a:t>
+            </a:r>
+            <a:endParaRPr lang="en-US" sz="900" dirty="0"/>
+          </a:p>
+        </p:txBody>
+      </p:sp>
     </p:spTree>
   </p:cSld>
   <p:clrMapOvr>
@@ -6682,6 +6947,59 @@
           </a:p>
         </p:txBody>
       </p:sp>
+      <p:sp>
+        <p:nvSpPr>
+          <p:cNvPr id="9" name="Text 7"/>
+          <p:cNvSpPr/>
+          <p:nvPr/>
+        </p:nvSpPr>
+        <p:spPr>
+          <a:xfrm>
+            <a:off x="502920" y="6583680"/>
+            <a:ext cx="11338560" cy="201168"/>
+          </a:xfrm>
+          <a:prstGeom prst="rect">
+            <a:avLst/>
+          </a:prstGeom>
+          <a:noFill/>
+          <a:ln/>
+        </p:spPr>
+        <p:txBody>
+          <a:bodyPr wrap="square" lIns="0" tIns="0" rIns="0" bIns="0" rtlCol="0" anchor="ctr"/>
+          <a:lstStyle/>
+          <a:p>
+            <a:pPr indent="0" marL="0">
+              <a:buNone/>
+            </a:pPr>
+            <a:r>
+              <a:rPr lang="en-US" sz="900" b="1" dirty="0">
+                <a:solidFill>
+                  <a:srgbClr val="E8A33D"/>
+                </a:solidFill>
+                <a:latin typeface="Consolas" pitchFamily="34" charset="0"/>
+                <a:ea typeface="Consolas" pitchFamily="34" charset="-122"/>
+                <a:cs typeface="Consolas" pitchFamily="34" charset="-120"/>
+              </a:rPr>
+              <a:t>‹code›  </a:t>
+            </a:r>
+            <a:pPr indent="0" marL="0">
+              <a:buNone/>
+            </a:pPr>
+            <a:r>
+              <a:rPr lang="en-US" sz="900" dirty="0">
+                <a:solidFill>
+                  <a:srgbClr val="6B7280"/>
+                </a:solidFill>
+                <a:latin typeface="Consolas" pitchFamily="34" charset="0"/>
+                <a:ea typeface="Consolas" pitchFamily="34" charset="-122"/>
+                <a:cs typeface="Consolas" pitchFamily="34" charset="-120"/>
+              </a:rPr>
+              <a:t>src/tools/retrieval_executor.py:29 ALLOWED_QUERIES（字母表）· :33-37 DEFAULT_POLICY · :53 normalize_policy（拼句子）</a:t>
+            </a:r>
+            <a:endParaRPr lang="en-US" sz="900" dirty="0"/>
+          </a:p>
+        </p:txBody>
+      </p:sp>
     </p:spTree>
   </p:cSld>
   <p:clrMapOvr>
@@ -7201,6 +7519,59 @@
           </a:p>
         </p:txBody>
       </p:sp>
+      <p:sp>
+        <p:nvSpPr>
+          <p:cNvPr id="13" name="Text 11"/>
+          <p:cNvSpPr/>
+          <p:nvPr/>
+        </p:nvSpPr>
+        <p:spPr>
+          <a:xfrm>
+            <a:off x="502920" y="6583680"/>
+            <a:ext cx="11338560" cy="201168"/>
+          </a:xfrm>
+          <a:prstGeom prst="rect">
+            <a:avLst/>
+          </a:prstGeom>
+          <a:noFill/>
+          <a:ln/>
+        </p:spPr>
+        <p:txBody>
+          <a:bodyPr wrap="square" lIns="0" tIns="0" rIns="0" bIns="0" rtlCol="0" anchor="ctr"/>
+          <a:lstStyle/>
+          <a:p>
+            <a:pPr indent="0" marL="0">
+              <a:buNone/>
+            </a:pPr>
+            <a:r>
+              <a:rPr lang="en-US" sz="900" b="1" dirty="0">
+                <a:solidFill>
+                  <a:srgbClr val="E8A33D"/>
+                </a:solidFill>
+                <a:latin typeface="Consolas" pitchFamily="34" charset="0"/>
+                <a:ea typeface="Consolas" pitchFamily="34" charset="-122"/>
+                <a:cs typeface="Consolas" pitchFamily="34" charset="-120"/>
+              </a:rPr>
+              <a:t>‹code›  </a:t>
+            </a:r>
+            <a:pPr indent="0" marL="0">
+              <a:buNone/>
+            </a:pPr>
+            <a:r>
+              <a:rPr lang="en-US" sz="900" dirty="0">
+                <a:solidFill>
+                  <a:srgbClr val="6B7280"/>
+                </a:solidFill>
+                <a:latin typeface="Consolas" pitchFamily="34" charset="0"/>
+                <a:ea typeface="Consolas" pitchFamily="34" charset="-122"/>
+                <a:cs typeface="Consolas" pitchFamily="34" charset="-120"/>
+              </a:rPr>
+              <a:t>src/flows/serving_flow.py:85-93 execute_policy → retrieved_context 注入 ｜ simulation_crew.py:42-50 data_retriever 無 tools</a:t>
+            </a:r>
+            <a:endParaRPr lang="en-US" sz="900" dirty="0"/>
+          </a:p>
+        </p:txBody>
+      </p:sp>
     </p:spTree>
   </p:cSld>
   <p:clrMapOvr>
@@ -8099,6 +8470,59 @@
           </a:p>
         </p:txBody>
       </p:sp>
+      <p:sp>
+        <p:nvSpPr>
+          <p:cNvPr id="27" name="Text 25"/>
+          <p:cNvSpPr/>
+          <p:nvPr/>
+        </p:nvSpPr>
+        <p:spPr>
+          <a:xfrm>
+            <a:off x="502920" y="6583680"/>
+            <a:ext cx="11338560" cy="201168"/>
+          </a:xfrm>
+          <a:prstGeom prst="rect">
+            <a:avLst/>
+          </a:prstGeom>
+          <a:noFill/>
+          <a:ln/>
+        </p:spPr>
+        <p:txBody>
+          <a:bodyPr wrap="square" lIns="0" tIns="0" rIns="0" bIns="0" rtlCol="0" anchor="ctr"/>
+          <a:lstStyle/>
+          <a:p>
+            <a:pPr indent="0" marL="0">
+              <a:buNone/>
+            </a:pPr>
+            <a:r>
+              <a:rPr lang="en-US" sz="900" b="1" dirty="0">
+                <a:solidFill>
+                  <a:srgbClr val="E8A33D"/>
+                </a:solidFill>
+                <a:latin typeface="Consolas" pitchFamily="34" charset="0"/>
+                <a:ea typeface="Consolas" pitchFamily="34" charset="-122"/>
+                <a:cs typeface="Consolas" pitchFamily="34" charset="-120"/>
+              </a:rPr>
+              <a:t>‹code›  </a:t>
+            </a:r>
+            <a:pPr indent="0" marL="0">
+              <a:buNone/>
+            </a:pPr>
+            <a:r>
+              <a:rPr lang="en-US" sz="900" dirty="0">
+                <a:solidFill>
+                  <a:srgbClr val="6B7280"/>
+                </a:solidFill>
+                <a:latin typeface="Consolas" pitchFamily="34" charset="0"/>
+                <a:ea typeface="Consolas" pitchFamily="34" charset="-122"/>
+                <a:cs typeface="Consolas" pitchFamily="34" charset="-120"/>
+              </a:rPr>
+              <a:t>src/tools/tool_loader.py:77 ast_safety_scan · :106 signature_ok · :120 trial_run · :156 _wrap_as_crewai_tool · :60 ReadOnlyKit</a:t>
+            </a:r>
+            <a:endParaRPr lang="en-US" sz="900" dirty="0"/>
+          </a:p>
+        </p:txBody>
+      </p:sp>
     </p:spTree>
   </p:cSld>
   <p:clrMapOvr>
@@ -8655,6 +9079,59 @@
           </a:p>
         </p:txBody>
       </p:sp>
+      <p:sp>
+        <p:nvSpPr>
+          <p:cNvPr id="13" name="Text 11"/>
+          <p:cNvSpPr/>
+          <p:nvPr/>
+        </p:nvSpPr>
+        <p:spPr>
+          <a:xfrm>
+            <a:off x="502920" y="6583680"/>
+            <a:ext cx="11338560" cy="201168"/>
+          </a:xfrm>
+          <a:prstGeom prst="rect">
+            <a:avLst/>
+          </a:prstGeom>
+          <a:noFill/>
+          <a:ln/>
+        </p:spPr>
+        <p:txBody>
+          <a:bodyPr wrap="square" lIns="0" tIns="0" rIns="0" bIns="0" rtlCol="0" anchor="ctr"/>
+          <a:lstStyle/>
+          <a:p>
+            <a:pPr indent="0" marL="0">
+              <a:buNone/>
+            </a:pPr>
+            <a:r>
+              <a:rPr lang="en-US" sz="900" b="1" dirty="0">
+                <a:solidFill>
+                  <a:srgbClr val="E8A33D"/>
+                </a:solidFill>
+                <a:latin typeface="Consolas" pitchFamily="34" charset="0"/>
+                <a:ea typeface="Consolas" pitchFamily="34" charset="-122"/>
+                <a:cs typeface="Consolas" pitchFamily="34" charset="-120"/>
+              </a:rPr>
+              <a:t>‹code›  </a:t>
+            </a:r>
+            <a:pPr indent="0" marL="0">
+              <a:buNone/>
+            </a:pPr>
+            <a:r>
+              <a:rPr lang="en-US" sz="900" dirty="0">
+                <a:solidFill>
+                  <a:srgbClr val="6B7280"/>
+                </a:solidFill>
+                <a:latin typeface="Consolas" pitchFamily="34" charset="0"/>
+                <a:ea typeface="Consolas" pitchFamily="34" charset="-122"/>
+                <a:cs typeface="Consolas" pitchFamily="34" charset="-120"/>
+              </a:rPr>
+              <a:t>src/tools/tool_loader.py:156-177 _wrap_as_crewai_tool（docstring→description）· simulation_crew.py:53-62 analyst tools=_load_analyst_tools()</a:t>
+            </a:r>
+            <a:endParaRPr lang="en-US" sz="900" dirty="0"/>
+          </a:p>
+        </p:txBody>
+      </p:sp>
     </p:spTree>
   </p:cSld>
   <p:clrMapOvr>
@@ -9163,6 +9640,59 @@
           </a:p>
         </p:txBody>
       </p:sp>
+      <p:sp>
+        <p:nvSpPr>
+          <p:cNvPr id="13" name="Text 11"/>
+          <p:cNvSpPr/>
+          <p:nvPr/>
+        </p:nvSpPr>
+        <p:spPr>
+          <a:xfrm>
+            <a:off x="502920" y="6583680"/>
+            <a:ext cx="11338560" cy="201168"/>
+          </a:xfrm>
+          <a:prstGeom prst="rect">
+            <a:avLst/>
+          </a:prstGeom>
+          <a:noFill/>
+          <a:ln/>
+        </p:spPr>
+        <p:txBody>
+          <a:bodyPr wrap="square" lIns="0" tIns="0" rIns="0" bIns="0" rtlCol="0" anchor="ctr"/>
+          <a:lstStyle/>
+          <a:p>
+            <a:pPr indent="0" marL="0">
+              <a:buNone/>
+            </a:pPr>
+            <a:r>
+              <a:rPr lang="en-US" sz="900" b="1" dirty="0">
+                <a:solidFill>
+                  <a:srgbClr val="E8A33D"/>
+                </a:solidFill>
+                <a:latin typeface="Consolas" pitchFamily="34" charset="0"/>
+                <a:ea typeface="Consolas" pitchFamily="34" charset="-122"/>
+                <a:cs typeface="Consolas" pitchFamily="34" charset="-120"/>
+              </a:rPr>
+              <a:t>‹code›  </a:t>
+            </a:r>
+            <a:pPr indent="0" marL="0">
+              <a:buNone/>
+            </a:pPr>
+            <a:r>
+              <a:rPr lang="en-US" sz="900" dirty="0">
+                <a:solidFill>
+                  <a:srgbClr val="6B7280"/>
+                </a:solidFill>
+                <a:latin typeface="Consolas" pitchFamily="34" charset="0"/>
+                <a:ea typeface="Consolas" pitchFamily="34" charset="-122"/>
+                <a:cs typeface="Consolas" pitchFamily="34" charset="-120"/>
+              </a:rPr>
+              <a:t>openevolve_evaluator.py:83-84 OPENEVOLVE_TASK_DIR · scripts/validate_holdout.py:25 切 holdout · create_sampled_dataset.py:8 disjoint</a:t>
+            </a:r>
+            <a:endParaRPr lang="en-US" sz="900" dirty="0"/>
+          </a:p>
+        </p:txBody>
+      </p:sp>
     </p:spTree>
   </p:cSld>
   <p:clrMapOvr>
@@ -9548,6 +10078,59 @@
           </a:p>
         </p:txBody>
       </p:sp>
+      <p:sp>
+        <p:nvSpPr>
+          <p:cNvPr id="11" name="Text 8"/>
+          <p:cNvSpPr/>
+          <p:nvPr/>
+        </p:nvSpPr>
+        <p:spPr>
+          <a:xfrm>
+            <a:off x="502920" y="6583680"/>
+            <a:ext cx="11338560" cy="201168"/>
+          </a:xfrm>
+          <a:prstGeom prst="rect">
+            <a:avLst/>
+          </a:prstGeom>
+          <a:noFill/>
+          <a:ln/>
+        </p:spPr>
+        <p:txBody>
+          <a:bodyPr wrap="square" lIns="0" tIns="0" rIns="0" bIns="0" rtlCol="0" anchor="ctr"/>
+          <a:lstStyle/>
+          <a:p>
+            <a:pPr indent="0" marL="0">
+              <a:buNone/>
+            </a:pPr>
+            <a:r>
+              <a:rPr lang="en-US" sz="900" b="1" dirty="0">
+                <a:solidFill>
+                  <a:srgbClr val="E8A33D"/>
+                </a:solidFill>
+                <a:latin typeface="Consolas" pitchFamily="34" charset="0"/>
+                <a:ea typeface="Consolas" pitchFamily="34" charset="-122"/>
+                <a:cs typeface="Consolas" pitchFamily="34" charset="-120"/>
+              </a:rPr>
+              <a:t>‹code›  </a:t>
+            </a:r>
+            <a:pPr indent="0" marL="0">
+              <a:buNone/>
+            </a:pPr>
+            <a:r>
+              <a:rPr lang="en-US" sz="900" dirty="0">
+                <a:solidFill>
+                  <a:srgbClr val="6B7280"/>
+                </a:solidFill>
+                <a:latin typeface="Consolas" pitchFamily="34" charset="0"/>
+                <a:ea typeface="Consolas" pitchFamily="34" charset="-122"/>
+                <a:cs typeface="Consolas" pitchFamily="34" charset="-120"/>
+              </a:rPr>
+              <a:t>config/openevolve_config.yaml:85-88 feature_dimensions（8×8）· openevolve_evaluator.py:47-59 _result(extra_metrics) · :174-177</a:t>
+            </a:r>
+            <a:endParaRPr lang="en-US" sz="900" dirty="0"/>
+          </a:p>
+        </p:txBody>
+      </p:sp>
     </p:spTree>
   </p:cSld>
   <p:clrMapOvr>
@@ -10745,6 +11328,59 @@
           </a:p>
         </p:txBody>
       </p:sp>
+      <p:sp>
+        <p:nvSpPr>
+          <p:cNvPr id="36" name="Text 34"/>
+          <p:cNvSpPr/>
+          <p:nvPr/>
+        </p:nvSpPr>
+        <p:spPr>
+          <a:xfrm>
+            <a:off x="502920" y="6583680"/>
+            <a:ext cx="11338560" cy="201168"/>
+          </a:xfrm>
+          <a:prstGeom prst="rect">
+            <a:avLst/>
+          </a:prstGeom>
+          <a:noFill/>
+          <a:ln/>
+        </p:spPr>
+        <p:txBody>
+          <a:bodyPr wrap="square" lIns="0" tIns="0" rIns="0" bIns="0" rtlCol="0" anchor="ctr"/>
+          <a:lstStyle/>
+          <a:p>
+            <a:pPr indent="0" marL="0">
+              <a:buNone/>
+            </a:pPr>
+            <a:r>
+              <a:rPr lang="en-US" sz="900" b="1" dirty="0">
+                <a:solidFill>
+                  <a:srgbClr val="E8A33D"/>
+                </a:solidFill>
+                <a:latin typeface="Consolas" pitchFamily="34" charset="0"/>
+                <a:ea typeface="Consolas" pitchFamily="34" charset="-122"/>
+                <a:cs typeface="Consolas" pitchFamily="34" charset="-120"/>
+              </a:rPr>
+              <a:t>‹code›  </a:t>
+            </a:r>
+            <a:pPr indent="0" marL="0">
+              <a:buNone/>
+            </a:pPr>
+            <a:r>
+              <a:rPr lang="en-US" sz="900" dirty="0">
+                <a:solidFill>
+                  <a:srgbClr val="6B7280"/>
+                </a:solidFill>
+                <a:latin typeface="Consolas" pitchFamily="34" charset="0"/>
+                <a:ea typeface="Consolas" pitchFamily="34" charset="-122"/>
+                <a:cs typeface="Consolas" pitchFamily="34" charset="-120"/>
+              </a:rPr>
+              <a:t>全程對照：docs/evolution_design_notes.md（設計與驗證數據的完整記錄）</a:t>
+            </a:r>
+            <a:endParaRPr lang="en-US" sz="900" dirty="0"/>
+          </a:p>
+        </p:txBody>
+      </p:sp>
     </p:spTree>
   </p:cSld>
   <p:clrMapOvr>
@@ -11202,6 +11838,59 @@
               <a:t>graceful fallback 會讓「沒裝上工具」偽裝成「分數正常」。驗證要查功能本身（tools 清單），不能只看分數。</a:t>
             </a:r>
             <a:endParaRPr lang="en-US" sz="1500" dirty="0"/>
+          </a:p>
+        </p:txBody>
+      </p:sp>
+      <p:sp>
+        <p:nvSpPr>
+          <p:cNvPr id="14" name="Text 12"/>
+          <p:cNvSpPr/>
+          <p:nvPr/>
+        </p:nvSpPr>
+        <p:spPr>
+          <a:xfrm>
+            <a:off x="502920" y="6583680"/>
+            <a:ext cx="11338560" cy="201168"/>
+          </a:xfrm>
+          <a:prstGeom prst="rect">
+            <a:avLst/>
+          </a:prstGeom>
+          <a:noFill/>
+          <a:ln/>
+        </p:spPr>
+        <p:txBody>
+          <a:bodyPr wrap="square" lIns="0" tIns="0" rIns="0" bIns="0" rtlCol="0" anchor="ctr"/>
+          <a:lstStyle/>
+          <a:p>
+            <a:pPr indent="0" marL="0">
+              <a:buNone/>
+            </a:pPr>
+            <a:r>
+              <a:rPr lang="en-US" sz="900" b="1" dirty="0">
+                <a:solidFill>
+                  <a:srgbClr val="E8A33D"/>
+                </a:solidFill>
+                <a:latin typeface="Consolas" pitchFamily="34" charset="0"/>
+                <a:ea typeface="Consolas" pitchFamily="34" charset="-122"/>
+                <a:cs typeface="Consolas" pitchFamily="34" charset="-120"/>
+              </a:rPr>
+              <a:t>‹code›  </a:t>
+            </a:r>
+            <a:pPr indent="0" marL="0">
+              <a:buNone/>
+            </a:pPr>
+            <a:r>
+              <a:rPr lang="en-US" sz="900" dirty="0">
+                <a:solidFill>
+                  <a:srgbClr val="8FA3C8"/>
+                </a:solidFill>
+                <a:latin typeface="Consolas" pitchFamily="34" charset="0"/>
+                <a:ea typeface="Consolas" pitchFamily="34" charset="-122"/>
+                <a:cs typeface="Consolas" pitchFamily="34" charset="-120"/>
+              </a:rPr>
+              <a:t>tool_loader.py:139-146 _safe_import（bug#1）· :156-177 docstring 轉移（bug#2）· simulation_crew.py:21-30 graceful [] 蓋住失敗</a:t>
+            </a:r>
+            <a:endParaRPr lang="en-US" sz="900" dirty="0"/>
           </a:p>
         </p:txBody>
       </p:sp>
@@ -12449,6 +13138,59 @@
           </a:p>
         </p:txBody>
       </p:sp>
+      <p:sp>
+        <p:nvSpPr>
+          <p:cNvPr id="7" name="Text 4"/>
+          <p:cNvSpPr/>
+          <p:nvPr/>
+        </p:nvSpPr>
+        <p:spPr>
+          <a:xfrm>
+            <a:off x="502920" y="6583680"/>
+            <a:ext cx="11338560" cy="201168"/>
+          </a:xfrm>
+          <a:prstGeom prst="rect">
+            <a:avLst/>
+          </a:prstGeom>
+          <a:noFill/>
+          <a:ln/>
+        </p:spPr>
+        <p:txBody>
+          <a:bodyPr wrap="square" lIns="0" tIns="0" rIns="0" bIns="0" rtlCol="0" anchor="ctr"/>
+          <a:lstStyle/>
+          <a:p>
+            <a:pPr indent="0" marL="0">
+              <a:buNone/>
+            </a:pPr>
+            <a:r>
+              <a:rPr lang="en-US" sz="900" b="1" dirty="0">
+                <a:solidFill>
+                  <a:srgbClr val="E8A33D"/>
+                </a:solidFill>
+                <a:latin typeface="Consolas" pitchFamily="34" charset="0"/>
+                <a:ea typeface="Consolas" pitchFamily="34" charset="-122"/>
+                <a:cs typeface="Consolas" pitchFamily="34" charset="-120"/>
+              </a:rPr>
+              <a:t>‹code›  </a:t>
+            </a:r>
+            <a:pPr indent="0" marL="0">
+              <a:buNone/>
+            </a:pPr>
+            <a:r>
+              <a:rPr lang="en-US" sz="900" dirty="0">
+                <a:solidFill>
+                  <a:srgbClr val="6B7280"/>
+                </a:solidFill>
+                <a:latin typeface="Consolas" pitchFamily="34" charset="0"/>
+                <a:ea typeface="Consolas" pitchFamily="34" charset="-122"/>
+                <a:cs typeface="Consolas" pitchFamily="34" charset="-120"/>
+              </a:rPr>
+              <a:t>docs/evolution_design_notes.md §12.4（接線前後對照）· §12.3（進化跑歷史）</a:t>
+            </a:r>
+            <a:endParaRPr lang="en-US" sz="900" dirty="0"/>
+          </a:p>
+        </p:txBody>
+      </p:sp>
     </p:spTree>
   </p:cSld>
   <p:clrMapOvr>
@@ -13312,6 +14054,59 @@
           </a:p>
         </p:txBody>
       </p:sp>
+      <p:sp>
+        <p:nvSpPr>
+          <p:cNvPr id="24" name="Text 22"/>
+          <p:cNvSpPr/>
+          <p:nvPr/>
+        </p:nvSpPr>
+        <p:spPr>
+          <a:xfrm>
+            <a:off x="502920" y="6583680"/>
+            <a:ext cx="11338560" cy="201168"/>
+          </a:xfrm>
+          <a:prstGeom prst="rect">
+            <a:avLst/>
+          </a:prstGeom>
+          <a:noFill/>
+          <a:ln/>
+        </p:spPr>
+        <p:txBody>
+          <a:bodyPr wrap="square" lIns="0" tIns="0" rIns="0" bIns="0" rtlCol="0" anchor="ctr"/>
+          <a:lstStyle/>
+          <a:p>
+            <a:pPr indent="0" marL="0">
+              <a:buNone/>
+            </a:pPr>
+            <a:r>
+              <a:rPr lang="en-US" sz="900" b="1" dirty="0">
+                <a:solidFill>
+                  <a:srgbClr val="E8A33D"/>
+                </a:solidFill>
+                <a:latin typeface="Consolas" pitchFamily="34" charset="0"/>
+                <a:ea typeface="Consolas" pitchFamily="34" charset="-122"/>
+                <a:cs typeface="Consolas" pitchFamily="34" charset="-120"/>
+              </a:rPr>
+              <a:t>‹code›  </a:t>
+            </a:r>
+            <a:pPr indent="0" marL="0">
+              <a:buNone/>
+            </a:pPr>
+            <a:r>
+              <a:rPr lang="en-US" sz="900" dirty="0">
+                <a:solidFill>
+                  <a:srgbClr val="6B7280"/>
+                </a:solidFill>
+                <a:latin typeface="Consolas" pitchFamily="34" charset="0"/>
+                <a:ea typeface="Consolas" pitchFamily="34" charset="-122"/>
+                <a:cs typeface="Consolas" pitchFamily="34" charset="-120"/>
+              </a:rPr>
+              <a:t>docs/evolution_design_notes.md §11（進度與 PR 對照）· §12.7（完整架構數據：baseline 0.72 → best 0.842）</a:t>
+            </a:r>
+            <a:endParaRPr lang="en-US" sz="900" dirty="0"/>
+          </a:p>
+        </p:txBody>
+      </p:sp>
     </p:spTree>
   </p:cSld>
   <p:clrMapOvr>
@@ -13499,6 +14294,59 @@
           </a:p>
         </p:txBody>
       </p:sp>
+      <p:sp>
+        <p:nvSpPr>
+          <p:cNvPr id="5" name="Text 3"/>
+          <p:cNvSpPr/>
+          <p:nvPr/>
+        </p:nvSpPr>
+        <p:spPr>
+          <a:xfrm>
+            <a:off x="502920" y="6583680"/>
+            <a:ext cx="11338560" cy="201168"/>
+          </a:xfrm>
+          <a:prstGeom prst="rect">
+            <a:avLst/>
+          </a:prstGeom>
+          <a:noFill/>
+          <a:ln/>
+        </p:spPr>
+        <p:txBody>
+          <a:bodyPr wrap="square" lIns="0" tIns="0" rIns="0" bIns="0" rtlCol="0" anchor="ctr"/>
+          <a:lstStyle/>
+          <a:p>
+            <a:pPr indent="0" marL="0">
+              <a:buNone/>
+            </a:pPr>
+            <a:r>
+              <a:rPr lang="en-US" sz="900" b="1" dirty="0">
+                <a:solidFill>
+                  <a:srgbClr val="E8A33D"/>
+                </a:solidFill>
+                <a:latin typeface="Consolas" pitchFamily="34" charset="0"/>
+                <a:ea typeface="Consolas" pitchFamily="34" charset="-122"/>
+                <a:cs typeface="Consolas" pitchFamily="34" charset="-120"/>
+              </a:rPr>
+              <a:t>‹code›  </a:t>
+            </a:r>
+            <a:pPr indent="0" marL="0">
+              <a:buNone/>
+            </a:pPr>
+            <a:r>
+              <a:rPr lang="en-US" sz="900" dirty="0">
+                <a:solidFill>
+                  <a:srgbClr val="8FA3C8"/>
+                </a:solidFill>
+                <a:latin typeface="Consolas" pitchFamily="34" charset="0"/>
+                <a:ea typeface="Consolas" pitchFamily="34" charset="-122"/>
+                <a:cs typeface="Consolas" pitchFamily="34" charset="-120"/>
+              </a:rPr>
+              <a:t>tests/test_retrieval_executor.py + tests/test_tool_loader.py（46 全綠）· docs/evolution_design_notes.md</a:t>
+            </a:r>
+            <a:endParaRPr lang="en-US" sz="900" dirty="0"/>
+          </a:p>
+        </p:txBody>
+      </p:sp>
     </p:spTree>
   </p:cSld>
   <p:clrMapOvr>
@@ -14079,6 +14927,59 @@
           </a:p>
         </p:txBody>
       </p:sp>
+      <p:sp>
+        <p:nvSpPr>
+          <p:cNvPr id="14" name="Text 12"/>
+          <p:cNvSpPr/>
+          <p:nvPr/>
+        </p:nvSpPr>
+        <p:spPr>
+          <a:xfrm>
+            <a:off x="502920" y="6583680"/>
+            <a:ext cx="11338560" cy="201168"/>
+          </a:xfrm>
+          <a:prstGeom prst="rect">
+            <a:avLst/>
+          </a:prstGeom>
+          <a:noFill/>
+          <a:ln/>
+        </p:spPr>
+        <p:txBody>
+          <a:bodyPr wrap="square" lIns="0" tIns="0" rIns="0" bIns="0" rtlCol="0" anchor="ctr"/>
+          <a:lstStyle/>
+          <a:p>
+            <a:pPr indent="0" marL="0">
+              <a:buNone/>
+            </a:pPr>
+            <a:r>
+              <a:rPr lang="en-US" sz="900" b="1" dirty="0">
+                <a:solidFill>
+                  <a:srgbClr val="E8A33D"/>
+                </a:solidFill>
+                <a:latin typeface="Consolas" pitchFamily="34" charset="0"/>
+                <a:ea typeface="Consolas" pitchFamily="34" charset="-122"/>
+                <a:cs typeface="Consolas" pitchFamily="34" charset="-120"/>
+              </a:rPr>
+              <a:t>‹code›  </a:t>
+            </a:r>
+            <a:pPr indent="0" marL="0">
+              <a:buNone/>
+            </a:pPr>
+            <a:r>
+              <a:rPr lang="en-US" sz="900" dirty="0">
+                <a:solidFill>
+                  <a:srgbClr val="6B7280"/>
+                </a:solidFill>
+                <a:latin typeface="Consolas" pitchFamily="34" charset="0"/>
+                <a:ea typeface="Consolas" pitchFamily="34" charset="-122"/>
+                <a:cs typeface="Consolas" pitchFamily="34" charset="-120"/>
+              </a:rPr>
+              <a:t>openevolve_evaluator.py:96 evaluate() · :106-108 combined_score = overall_quality · :149-151 取分項</a:t>
+            </a:r>
+            <a:endParaRPr lang="en-US" sz="900" dirty="0"/>
+          </a:p>
+        </p:txBody>
+      </p:sp>
     </p:spTree>
   </p:cSld>
   <p:clrMapOvr>
@@ -14755,6 +15656,59 @@
           </a:p>
         </p:txBody>
       </p:sp>
+      <p:sp>
+        <p:nvSpPr>
+          <p:cNvPr id="21" name="Text 19"/>
+          <p:cNvSpPr/>
+          <p:nvPr/>
+        </p:nvSpPr>
+        <p:spPr>
+          <a:xfrm>
+            <a:off x="502920" y="6583680"/>
+            <a:ext cx="11338560" cy="201168"/>
+          </a:xfrm>
+          <a:prstGeom prst="rect">
+            <a:avLst/>
+          </a:prstGeom>
+          <a:noFill/>
+          <a:ln/>
+        </p:spPr>
+        <p:txBody>
+          <a:bodyPr wrap="square" lIns="0" tIns="0" rIns="0" bIns="0" rtlCol="0" anchor="ctr"/>
+          <a:lstStyle/>
+          <a:p>
+            <a:pPr indent="0" marL="0">
+              <a:buNone/>
+            </a:pPr>
+            <a:r>
+              <a:rPr lang="en-US" sz="900" b="1" dirty="0">
+                <a:solidFill>
+                  <a:srgbClr val="E8A33D"/>
+                </a:solidFill>
+                <a:latin typeface="Consolas" pitchFamily="34" charset="0"/>
+                <a:ea typeface="Consolas" pitchFamily="34" charset="-122"/>
+                <a:cs typeface="Consolas" pitchFamily="34" charset="-120"/>
+              </a:rPr>
+              <a:t>‹code›  </a:t>
+            </a:r>
+            <a:pPr indent="0" marL="0">
+              <a:buNone/>
+            </a:pPr>
+            <a:r>
+              <a:rPr lang="en-US" sz="900" dirty="0">
+                <a:solidFill>
+                  <a:srgbClr val="6B7280"/>
+                </a:solidFill>
+                <a:latin typeface="Consolas" pitchFamily="34" charset="0"/>
+                <a:ea typeface="Consolas" pitchFamily="34" charset="-122"/>
+                <a:cs typeface="Consolas" pitchFamily="34" charset="-120"/>
+              </a:rPr>
+              <a:t>src/crews/simulation_crew.py:42 data_retriever · :53 analyst · :65 behavior_simulator · :89 crew(Process.sequential)</a:t>
+            </a:r>
+            <a:endParaRPr lang="en-US" sz="900" dirty="0"/>
+          </a:p>
+        </p:txBody>
+      </p:sp>
     </p:spTree>
   </p:cSld>
   <p:clrMapOvr>
@@ -15809,6 +16763,59 @@
           </a:p>
         </p:txBody>
       </p:sp>
+      <p:sp>
+        <p:nvSpPr>
+          <p:cNvPr id="31" name="Text 29"/>
+          <p:cNvSpPr/>
+          <p:nvPr/>
+        </p:nvSpPr>
+        <p:spPr>
+          <a:xfrm>
+            <a:off x="502920" y="6583680"/>
+            <a:ext cx="11338560" cy="201168"/>
+          </a:xfrm>
+          <a:prstGeom prst="rect">
+            <a:avLst/>
+          </a:prstGeom>
+          <a:noFill/>
+          <a:ln/>
+        </p:spPr>
+        <p:txBody>
+          <a:bodyPr wrap="square" lIns="0" tIns="0" rIns="0" bIns="0" rtlCol="0" anchor="ctr"/>
+          <a:lstStyle/>
+          <a:p>
+            <a:pPr indent="0" marL="0">
+              <a:buNone/>
+            </a:pPr>
+            <a:r>
+              <a:rPr lang="en-US" sz="900" b="1" dirty="0">
+                <a:solidFill>
+                  <a:srgbClr val="E8A33D"/>
+                </a:solidFill>
+                <a:latin typeface="Consolas" pitchFamily="34" charset="0"/>
+                <a:ea typeface="Consolas" pitchFamily="34" charset="-122"/>
+                <a:cs typeface="Consolas" pitchFamily="34" charset="-120"/>
+              </a:rPr>
+              <a:t>‹code›  </a:t>
+            </a:r>
+            <a:pPr indent="0" marL="0">
+              <a:buNone/>
+            </a:pPr>
+            <a:r>
+              <a:rPr lang="en-US" sz="900" dirty="0">
+                <a:solidFill>
+                  <a:srgbClr val="6B7280"/>
+                </a:solidFill>
+                <a:latin typeface="Consolas" pitchFamily="34" charset="0"/>
+                <a:ea typeface="Consolas" pitchFamily="34" charset="-122"/>
+                <a:cs typeface="Consolas" pitchFamily="34" charset="-120"/>
+              </a:rPr>
+              <a:t>config/openevolve_config.yaml:10 max_iterations · :18 diff_based_evolution:false · :71-88 database(islands/MAP-Elites)</a:t>
+            </a:r>
+            <a:endParaRPr lang="en-US" sz="900" dirty="0"/>
+          </a:p>
+        </p:txBody>
+      </p:sp>
     </p:spTree>
   </p:cSld>
   <p:clrMapOvr>
@@ -16223,6 +17230,59 @@
           </a:p>
         </p:txBody>
       </p:sp>
+      <p:sp>
+        <p:nvSpPr>
+          <p:cNvPr id="11" name="Text 8"/>
+          <p:cNvSpPr/>
+          <p:nvPr/>
+        </p:nvSpPr>
+        <p:spPr>
+          <a:xfrm>
+            <a:off x="502920" y="6583680"/>
+            <a:ext cx="11338560" cy="201168"/>
+          </a:xfrm>
+          <a:prstGeom prst="rect">
+            <a:avLst/>
+          </a:prstGeom>
+          <a:noFill/>
+          <a:ln/>
+        </p:spPr>
+        <p:txBody>
+          <a:bodyPr wrap="square" lIns="0" tIns="0" rIns="0" bIns="0" rtlCol="0" anchor="ctr"/>
+          <a:lstStyle/>
+          <a:p>
+            <a:pPr indent="0" marL="0">
+              <a:buNone/>
+            </a:pPr>
+            <a:r>
+              <a:rPr lang="en-US" sz="900" b="1" dirty="0">
+                <a:solidFill>
+                  <a:srgbClr val="E8A33D"/>
+                </a:solidFill>
+                <a:latin typeface="Consolas" pitchFamily="34" charset="0"/>
+                <a:ea typeface="Consolas" pitchFamily="34" charset="-122"/>
+                <a:cs typeface="Consolas" pitchFamily="34" charset="-120"/>
+              </a:rPr>
+              <a:t>‹code›  </a:t>
+            </a:r>
+            <a:pPr indent="0" marL="0">
+              <a:buNone/>
+            </a:pPr>
+            <a:r>
+              <a:rPr lang="en-US" sz="900" dirty="0">
+                <a:solidFill>
+                  <a:srgbClr val="6B7280"/>
+                </a:solidFill>
+                <a:latin typeface="Consolas" pitchFamily="34" charset="0"/>
+                <a:ea typeface="Consolas" pitchFamily="34" charset="-122"/>
+                <a:cs typeface="Consolas" pitchFamily="34" charset="-120"/>
+              </a:rPr>
+              <a:t>docs/evolution_design_notes.md §2（10 方向總表）· §10 Rate Limit 五層防護 · openevolve_config.yaml:32 retries</a:t>
+            </a:r>
+            <a:endParaRPr lang="en-US" sz="900" dirty="0"/>
+          </a:p>
+        </p:txBody>
+      </p:sp>
     </p:spTree>
   </p:cSld>
   <p:clrMapOvr>
@@ -16557,6 +17617,59 @@
           </a:p>
         </p:txBody>
       </p:sp>
+      <p:sp>
+        <p:nvSpPr>
+          <p:cNvPr id="11" name="Text 8"/>
+          <p:cNvSpPr/>
+          <p:nvPr/>
+        </p:nvSpPr>
+        <p:spPr>
+          <a:xfrm>
+            <a:off x="502920" y="6583680"/>
+            <a:ext cx="11338560" cy="201168"/>
+          </a:xfrm>
+          <a:prstGeom prst="rect">
+            <a:avLst/>
+          </a:prstGeom>
+          <a:noFill/>
+          <a:ln/>
+        </p:spPr>
+        <p:txBody>
+          <a:bodyPr wrap="square" lIns="0" tIns="0" rIns="0" bIns="0" rtlCol="0" anchor="ctr"/>
+          <a:lstStyle/>
+          <a:p>
+            <a:pPr indent="0" marL="0">
+              <a:buNone/>
+            </a:pPr>
+            <a:r>
+              <a:rPr lang="en-US" sz="900" b="1" dirty="0">
+                <a:solidFill>
+                  <a:srgbClr val="E8A33D"/>
+                </a:solidFill>
+                <a:latin typeface="Consolas" pitchFamily="34" charset="0"/>
+                <a:ea typeface="Consolas" pitchFamily="34" charset="-122"/>
+                <a:cs typeface="Consolas" pitchFamily="34" charset="-120"/>
+              </a:rPr>
+              <a:t>‹code›  </a:t>
+            </a:r>
+            <a:pPr indent="0" marL="0">
+              <a:buNone/>
+            </a:pPr>
+            <a:r>
+              <a:rPr lang="en-US" sz="900" dirty="0">
+                <a:solidFill>
+                  <a:srgbClr val="6B7280"/>
+                </a:solidFill>
+                <a:latin typeface="Consolas" pitchFamily="34" charset="0"/>
+                <a:ea typeface="Consolas" pitchFamily="34" charset="-122"/>
+                <a:cs typeface="Consolas" pitchFamily="34" charset="-120"/>
+              </a:rPr>
+              <a:t>openevolve_evaluator.py:133-137 timeout fallback · :179-184 exception fallback（都回 _result(0.0)）</a:t>
+            </a:r>
+            <a:endParaRPr lang="en-US" sz="900" dirty="0"/>
+          </a:p>
+        </p:txBody>
+      </p:sp>
     </p:spTree>
   </p:cSld>
   <p:clrMapOvr>
@@ -17540,8 +18653,8 @@
         </p:nvSpPr>
         <p:spPr>
           <a:xfrm>
-            <a:off x="548640" y="6355080"/>
-            <a:ext cx="10972800" cy="365760"/>
+            <a:off x="548640" y="6217920"/>
+            <a:ext cx="10972800" cy="274320"/>
           </a:xfrm>
           <a:prstGeom prst="rect">
             <a:avLst/>
@@ -17568,6 +18681,59 @@
               <a:t>原本只有 L1 有防護（tasks.yaml 凍結），L2–L5 全裸露 — 這張是全場骨架</a:t>
             </a:r>
             <a:endParaRPr lang="en-US" sz="1250" dirty="0"/>
+          </a:p>
+        </p:txBody>
+      </p:sp>
+      <p:sp>
+        <p:nvSpPr>
+          <p:cNvPr id="31" name="Text 29"/>
+          <p:cNvSpPr/>
+          <p:nvPr/>
+        </p:nvSpPr>
+        <p:spPr>
+          <a:xfrm>
+            <a:off x="502920" y="6583680"/>
+            <a:ext cx="11338560" cy="201168"/>
+          </a:xfrm>
+          <a:prstGeom prst="rect">
+            <a:avLst/>
+          </a:prstGeom>
+          <a:noFill/>
+          <a:ln/>
+        </p:spPr>
+        <p:txBody>
+          <a:bodyPr wrap="square" lIns="0" tIns="0" rIns="0" bIns="0" rtlCol="0" anchor="ctr"/>
+          <a:lstStyle/>
+          <a:p>
+            <a:pPr indent="0" marL="0">
+              <a:buNone/>
+            </a:pPr>
+            <a:r>
+              <a:rPr lang="en-US" sz="900" b="1" dirty="0">
+                <a:solidFill>
+                  <a:srgbClr val="E8A33D"/>
+                </a:solidFill>
+                <a:latin typeface="Consolas" pitchFamily="34" charset="0"/>
+                <a:ea typeface="Consolas" pitchFamily="34" charset="-122"/>
+                <a:cs typeface="Consolas" pitchFamily="34" charset="-120"/>
+              </a:rPr>
+              <a:t>‹code›  </a:t>
+            </a:r>
+            <a:pPr indent="0" marL="0">
+              <a:buNone/>
+            </a:pPr>
+            <a:r>
+              <a:rPr lang="en-US" sz="900" dirty="0">
+                <a:solidFill>
+                  <a:srgbClr val="6B7280"/>
+                </a:solidFill>
+                <a:latin typeface="Consolas" pitchFamily="34" charset="0"/>
+                <a:ea typeface="Consolas" pitchFamily="34" charset="-122"/>
+                <a:cs typeface="Consolas" pitchFamily="34" charset="-120"/>
+              </a:rPr>
+              <a:t>docs/evolution_design_notes.md §3（5 層分類表）· 防護落地：interaction_tool_wrapper.py · retrieval_executor.py · tool_loader.py</a:t>
+            </a:r>
+            <a:endParaRPr lang="en-US" sz="900" dirty="0"/>
           </a:p>
         </p:txBody>
       </p:sp>
@@ -17780,6 +18946,59 @@
               <a:t>這就是為什麼有些突變看似無害，卻造成崩潰——單一純量分數無法做 credit assignment。</a:t>
             </a:r>
             <a:endParaRPr lang="en-US" sz="1700" dirty="0"/>
+          </a:p>
+        </p:txBody>
+      </p:sp>
+      <p:sp>
+        <p:nvSpPr>
+          <p:cNvPr id="6" name="Text 4"/>
+          <p:cNvSpPr/>
+          <p:nvPr/>
+        </p:nvSpPr>
+        <p:spPr>
+          <a:xfrm>
+            <a:off x="502920" y="6583680"/>
+            <a:ext cx="11338560" cy="201168"/>
+          </a:xfrm>
+          <a:prstGeom prst="rect">
+            <a:avLst/>
+          </a:prstGeom>
+          <a:noFill/>
+          <a:ln/>
+        </p:spPr>
+        <p:txBody>
+          <a:bodyPr wrap="square" lIns="0" tIns="0" rIns="0" bIns="0" rtlCol="0" anchor="ctr"/>
+          <a:lstStyle/>
+          <a:p>
+            <a:pPr indent="0" marL="0">
+              <a:buNone/>
+            </a:pPr>
+            <a:r>
+              <a:rPr lang="en-US" sz="900" b="1" dirty="0">
+                <a:solidFill>
+                  <a:srgbClr val="E8A33D"/>
+                </a:solidFill>
+                <a:latin typeface="Consolas" pitchFamily="34" charset="0"/>
+                <a:ea typeface="Consolas" pitchFamily="34" charset="-122"/>
+                <a:cs typeface="Consolas" pitchFamily="34" charset="-120"/>
+              </a:rPr>
+              <a:t>‹code›  </a:t>
+            </a:r>
+            <a:pPr indent="0" marL="0">
+              <a:buNone/>
+            </a:pPr>
+            <a:r>
+              <a:rPr lang="en-US" sz="900" dirty="0">
+                <a:solidFill>
+                  <a:srgbClr val="8FA3C8"/>
+                </a:solidFill>
+                <a:latin typeface="Consolas" pitchFamily="34" charset="0"/>
+                <a:ea typeface="Consolas" pitchFamily="34" charset="-122"/>
+                <a:cs typeface="Consolas" pitchFamily="34" charset="-120"/>
+              </a:rPr>
+              <a:t>docs/evolution_design_notes.md §3（關鍵洞察）— 解法是 L0 把盲區變訊號</a:t>
+            </a:r>
+            <a:endParaRPr lang="en-US" sz="900" dirty="0"/>
           </a:p>
         </p:txBody>
       </p:sp>

</xml_diff>

<commit_message>
docs: fix L-numbering collision in deck 1 (build.js)
Same fix as the unified deck: the failure-taxonomy slide labelled the 5
failure modes L1–L5 while Part 3 uses L0/L1/L2 for the three defenses, so
"L1"/"L2" meant two different things. Relabel the failure modes ①–⑤ and
note that L0/L1/L2 refers only to the defenses.

Co-Authored-By: Claude Opus 4.8 <noreply@anthropic.com>
</commit_message>
<xml_diff>
--- a/docs/slides/OpenEvolve_CrewAI_教學投影片.pptx
+++ b/docs/slides/OpenEvolve_CrewAI_教學投影片.pptx
@@ -17873,21 +17873,21 @@
           <a:bodyPr wrap="square" lIns="0" tIns="0" rIns="0" bIns="0" rtlCol="0" anchor="ctr"/>
           <a:lstStyle/>
           <a:p>
-            <a:pPr indent="0" marL="0">
-              <a:buNone/>
-            </a:pPr>
-            <a:r>
-              <a:rPr lang="en-US" sz="2200" b="1" dirty="0">
+            <a:pPr algn="ctr" indent="0" marL="0">
+              <a:buNone/>
+            </a:pPr>
+            <a:r>
+              <a:rPr lang="en-US" sz="2400" b="1" dirty="0">
                 <a:solidFill>
                   <a:srgbClr val="C0453B"/>
                 </a:solidFill>
-                <a:latin typeface="Consolas" pitchFamily="34" charset="0"/>
-                <a:ea typeface="Consolas" pitchFamily="34" charset="-122"/>
-                <a:cs typeface="Consolas" pitchFamily="34" charset="-120"/>
-              </a:rPr>
-              <a:t>L1</a:t>
-            </a:r>
-            <a:endParaRPr lang="en-US" sz="2200" dirty="0"/>
+                <a:latin typeface="Georgia" pitchFamily="34" charset="0"/>
+                <a:ea typeface="Georgia" pitchFamily="34" charset="-122"/>
+                <a:cs typeface="Georgia" pitchFamily="34" charset="-120"/>
+              </a:rPr>
+              <a:t>①</a:t>
+            </a:r>
+            <a:endParaRPr lang="en-US" sz="2400" dirty="0"/>
           </a:p>
         </p:txBody>
       </p:sp>
@@ -18042,21 +18042,21 @@
           <a:bodyPr wrap="square" lIns="0" tIns="0" rIns="0" bIns="0" rtlCol="0" anchor="ctr"/>
           <a:lstStyle/>
           <a:p>
-            <a:pPr indent="0" marL="0">
-              <a:buNone/>
-            </a:pPr>
-            <a:r>
-              <a:rPr lang="en-US" sz="2200" b="1" dirty="0">
+            <a:pPr algn="ctr" indent="0" marL="0">
+              <a:buNone/>
+            </a:pPr>
+            <a:r>
+              <a:rPr lang="en-US" sz="2400" b="1" dirty="0">
                 <a:solidFill>
                   <a:srgbClr val="E8A33D"/>
                 </a:solidFill>
-                <a:latin typeface="Consolas" pitchFamily="34" charset="0"/>
-                <a:ea typeface="Consolas" pitchFamily="34" charset="-122"/>
-                <a:cs typeface="Consolas" pitchFamily="34" charset="-120"/>
-              </a:rPr>
-              <a:t>L2</a:t>
-            </a:r>
-            <a:endParaRPr lang="en-US" sz="2200" dirty="0"/>
+                <a:latin typeface="Georgia" pitchFamily="34" charset="0"/>
+                <a:ea typeface="Georgia" pitchFamily="34" charset="-122"/>
+                <a:cs typeface="Georgia" pitchFamily="34" charset="-120"/>
+              </a:rPr>
+              <a:t>②</a:t>
+            </a:r>
+            <a:endParaRPr lang="en-US" sz="2400" dirty="0"/>
           </a:p>
         </p:txBody>
       </p:sp>
@@ -18211,21 +18211,21 @@
           <a:bodyPr wrap="square" lIns="0" tIns="0" rIns="0" bIns="0" rtlCol="0" anchor="ctr"/>
           <a:lstStyle/>
           <a:p>
-            <a:pPr indent="0" marL="0">
-              <a:buNone/>
-            </a:pPr>
-            <a:r>
-              <a:rPr lang="en-US" sz="2200" b="1" dirty="0">
+            <a:pPr algn="ctr" indent="0" marL="0">
+              <a:buNone/>
+            </a:pPr>
+            <a:r>
+              <a:rPr lang="en-US" sz="2400" b="1" dirty="0">
                 <a:solidFill>
                   <a:srgbClr val="E8A33D"/>
                 </a:solidFill>
-                <a:latin typeface="Consolas" pitchFamily="34" charset="0"/>
-                <a:ea typeface="Consolas" pitchFamily="34" charset="-122"/>
-                <a:cs typeface="Consolas" pitchFamily="34" charset="-120"/>
-              </a:rPr>
-              <a:t>L3</a:t>
-            </a:r>
-            <a:endParaRPr lang="en-US" sz="2200" dirty="0"/>
+                <a:latin typeface="Georgia" pitchFamily="34" charset="0"/>
+                <a:ea typeface="Georgia" pitchFamily="34" charset="-122"/>
+                <a:cs typeface="Georgia" pitchFamily="34" charset="-120"/>
+              </a:rPr>
+              <a:t>③</a:t>
+            </a:r>
+            <a:endParaRPr lang="en-US" sz="2400" dirty="0"/>
           </a:p>
         </p:txBody>
       </p:sp>
@@ -18380,21 +18380,21 @@
           <a:bodyPr wrap="square" lIns="0" tIns="0" rIns="0" bIns="0" rtlCol="0" anchor="ctr"/>
           <a:lstStyle/>
           <a:p>
-            <a:pPr indent="0" marL="0">
-              <a:buNone/>
-            </a:pPr>
-            <a:r>
-              <a:rPr lang="en-US" sz="2200" b="1" dirty="0">
+            <a:pPr algn="ctr" indent="0" marL="0">
+              <a:buNone/>
+            </a:pPr>
+            <a:r>
+              <a:rPr lang="en-US" sz="2400" b="1" dirty="0">
                 <a:solidFill>
                   <a:srgbClr val="3A5BA0"/>
                 </a:solidFill>
-                <a:latin typeface="Consolas" pitchFamily="34" charset="0"/>
-                <a:ea typeface="Consolas" pitchFamily="34" charset="-122"/>
-                <a:cs typeface="Consolas" pitchFamily="34" charset="-120"/>
-              </a:rPr>
-              <a:t>L4</a:t>
-            </a:r>
-            <a:endParaRPr lang="en-US" sz="2200" dirty="0"/>
+                <a:latin typeface="Georgia" pitchFamily="34" charset="0"/>
+                <a:ea typeface="Georgia" pitchFamily="34" charset="-122"/>
+                <a:cs typeface="Georgia" pitchFamily="34" charset="-120"/>
+              </a:rPr>
+              <a:t>④</a:t>
+            </a:r>
+            <a:endParaRPr lang="en-US" sz="2400" dirty="0"/>
           </a:p>
         </p:txBody>
       </p:sp>
@@ -18549,57 +18549,57 @@
           <a:bodyPr wrap="square" lIns="0" tIns="0" rIns="0" bIns="0" rtlCol="0" anchor="ctr"/>
           <a:lstStyle/>
           <a:p>
-            <a:pPr indent="0" marL="0">
-              <a:buNone/>
-            </a:pPr>
-            <a:r>
-              <a:rPr lang="en-US" sz="2200" b="1" dirty="0">
+            <a:pPr algn="ctr" indent="0" marL="0">
+              <a:buNone/>
+            </a:pPr>
+            <a:r>
+              <a:rPr lang="en-US" sz="2400" b="1" dirty="0">
                 <a:solidFill>
                   <a:srgbClr val="3A5BA0"/>
-                </a:solidFill>
-                <a:latin typeface="Consolas" pitchFamily="34" charset="0"/>
-                <a:ea typeface="Consolas" pitchFamily="34" charset="-122"/>
-                <a:cs typeface="Consolas" pitchFamily="34" charset="-120"/>
-              </a:rPr>
-              <a:t>L5</a:t>
-            </a:r>
-            <a:endParaRPr lang="en-US" sz="2200" dirty="0"/>
-          </a:p>
-        </p:txBody>
-      </p:sp>
-      <p:sp>
-        <p:nvSpPr>
-          <p:cNvPr id="28" name="Text 26"/>
-          <p:cNvSpPr/>
-          <p:nvPr/>
-        </p:nvSpPr>
-        <p:spPr>
-          <a:xfrm>
-            <a:off x="1828800" y="5349240"/>
-            <a:ext cx="2377440" cy="786384"/>
-          </a:xfrm>
-          <a:prstGeom prst="rect">
-            <a:avLst/>
-          </a:prstGeom>
-          <a:noFill/>
-          <a:ln/>
-        </p:spPr>
-        <p:txBody>
-          <a:bodyPr wrap="square" lIns="0" tIns="0" rIns="0" bIns="0" rtlCol="0" anchor="ctr"/>
-          <a:lstStyle/>
-          <a:p>
-            <a:pPr indent="0" marL="0">
-              <a:buNone/>
-            </a:pPr>
-            <a:r>
-              <a:rPr lang="en-US" sz="1600" b="1" dirty="0">
-                <a:solidFill>
-                  <a:srgbClr val="1E2761"/>
                 </a:solidFill>
                 <a:latin typeface="Georgia" pitchFamily="34" charset="0"/>
                 <a:ea typeface="Georgia" pitchFamily="34" charset="-122"/>
                 <a:cs typeface="Georgia" pitchFamily="34" charset="-120"/>
               </a:rPr>
+              <a:t>⑤</a:t>
+            </a:r>
+            <a:endParaRPr lang="en-US" sz="2400" dirty="0"/>
+          </a:p>
+        </p:txBody>
+      </p:sp>
+      <p:sp>
+        <p:nvSpPr>
+          <p:cNvPr id="28" name="Text 26"/>
+          <p:cNvSpPr/>
+          <p:nvPr/>
+        </p:nvSpPr>
+        <p:spPr>
+          <a:xfrm>
+            <a:off x="1828800" y="5349240"/>
+            <a:ext cx="2377440" cy="786384"/>
+          </a:xfrm>
+          <a:prstGeom prst="rect">
+            <a:avLst/>
+          </a:prstGeom>
+          <a:noFill/>
+          <a:ln/>
+        </p:spPr>
+        <p:txBody>
+          <a:bodyPr wrap="square" lIns="0" tIns="0" rIns="0" bIns="0" rtlCol="0" anchor="ctr"/>
+          <a:lstStyle/>
+          <a:p>
+            <a:pPr indent="0" marL="0">
+              <a:buNone/>
+            </a:pPr>
+            <a:r>
+              <a:rPr lang="en-US" sz="1600" b="1" dirty="0">
+                <a:solidFill>
+                  <a:srgbClr val="1E2761"/>
+                </a:solidFill>
+                <a:latin typeface="Georgia" pitchFamily="34" charset="0"/>
+                <a:ea typeface="Georgia" pitchFamily="34" charset="-122"/>
+                <a:cs typeface="Georgia" pitchFamily="34" charset="-120"/>
+              </a:rPr>
               <a:t>下游契約</a:t>
             </a:r>
             <a:endParaRPr lang="en-US" sz="1600" dirty="0"/>
@@ -18678,7 +18678,7 @@
                 <a:ea typeface="Calibri" pitchFamily="34" charset="-122"/>
                 <a:cs typeface="Calibri" pitchFamily="34" charset="-120"/>
               </a:rPr>
-              <a:t>原本只有 L1 有防護（tasks.yaml 凍結），L2–L5 全裸露 — 這張是全場骨架</a:t>
+              <a:t>原本只有①有防護（tasks.yaml 凍結），②–⑤全裸露 — 這張是全場骨架（之後的解法用 L0/L1/L2，別跟這 5 層混淆）</a:t>
             </a:r>
             <a:endParaRPr lang="en-US" sz="1250" dirty="0"/>
           </a:p>

</xml_diff>